<commit_message>
update from app 2026-09-12 09:41:43
</commit_message>
<xml_diff>
--- a/Sergey.pptx
+++ b/Sergey.pptx
@@ -7,6 +7,7 @@
   <p:sldIdLst>
     <p:sldId id="256" r:id="rId2"/>
     <p:sldId id="257" r:id="rId3"/>
+    <p:sldId id="258" r:id="rId4"/>
   </p:sldIdLst>
   <p:sldSz cx="12192000" cy="6858000"/>
   <p:notesSz cx="6858000" cy="9144000"/>
@@ -105,6 +106,11 @@
       </a:defRPr>
     </a:lvl9pPr>
   </p:defaultTextStyle>
+  <p:extLst>
+    <p:ext uri="{EFAFB233-063F-42B5-8137-9DF3F51BA10A}">
+      <p15:sldGuideLst xmlns:p15="http://schemas.microsoft.com/office/powerpoint/2012/main"/>
+    </p:ext>
+  </p:extLst>
 </p:presentation>
 </file>
 
@@ -276,7 +282,7 @@
           <a:p>
             <a:fld id="{93646227-2445-453E-B510-42801F92B7A6}" type="datetimeFigureOut">
               <a:rPr lang="ru-RU" smtClean="0"/>
-              <a:t>02.09.2026</a:t>
+              <a:t>12.09.2026</a:t>
             </a:fld>
             <a:endParaRPr lang="ru-RU"/>
           </a:p>
@@ -504,7 +510,7 @@
           <a:p>
             <a:fld id="{93646227-2445-453E-B510-42801F92B7A6}" type="datetimeFigureOut">
               <a:rPr lang="ru-RU" smtClean="0"/>
-              <a:t>02.09.2026</a:t>
+              <a:t>12.09.2026</a:t>
             </a:fld>
             <a:endParaRPr lang="ru-RU"/>
           </a:p>
@@ -684,7 +690,7 @@
           <a:p>
             <a:fld id="{93646227-2445-453E-B510-42801F92B7A6}" type="datetimeFigureOut">
               <a:rPr lang="ru-RU" smtClean="0"/>
-              <a:t>02.09.2026</a:t>
+              <a:t>12.09.2026</a:t>
             </a:fld>
             <a:endParaRPr lang="ru-RU"/>
           </a:p>
@@ -854,7 +860,7 @@
           <a:p>
             <a:fld id="{93646227-2445-453E-B510-42801F92B7A6}" type="datetimeFigureOut">
               <a:rPr lang="ru-RU" smtClean="0"/>
-              <a:t>02.09.2026</a:t>
+              <a:t>12.09.2026</a:t>
             </a:fld>
             <a:endParaRPr lang="ru-RU"/>
           </a:p>
@@ -1108,7 +1114,7 @@
           <a:p>
             <a:fld id="{93646227-2445-453E-B510-42801F92B7A6}" type="datetimeFigureOut">
               <a:rPr lang="ru-RU" smtClean="0"/>
-              <a:t>02.09.2026</a:t>
+              <a:t>12.09.2026</a:t>
             </a:fld>
             <a:endParaRPr lang="ru-RU"/>
           </a:p>
@@ -1434,7 +1440,7 @@
           <a:p>
             <a:fld id="{93646227-2445-453E-B510-42801F92B7A6}" type="datetimeFigureOut">
               <a:rPr lang="ru-RU" smtClean="0"/>
-              <a:t>02.09.2026</a:t>
+              <a:t>12.09.2026</a:t>
             </a:fld>
             <a:endParaRPr lang="ru-RU"/>
           </a:p>
@@ -1885,7 +1891,7 @@
           <a:p>
             <a:fld id="{93646227-2445-453E-B510-42801F92B7A6}" type="datetimeFigureOut">
               <a:rPr lang="ru-RU" smtClean="0"/>
-              <a:t>02.09.2026</a:t>
+              <a:t>12.09.2026</a:t>
             </a:fld>
             <a:endParaRPr lang="ru-RU"/>
           </a:p>
@@ -2003,7 +2009,7 @@
           <a:p>
             <a:fld id="{93646227-2445-453E-B510-42801F92B7A6}" type="datetimeFigureOut">
               <a:rPr lang="ru-RU" smtClean="0"/>
-              <a:t>02.09.2026</a:t>
+              <a:t>12.09.2026</a:t>
             </a:fld>
             <a:endParaRPr lang="ru-RU"/>
           </a:p>
@@ -2098,7 +2104,7 @@
           <a:p>
             <a:fld id="{93646227-2445-453E-B510-42801F92B7A6}" type="datetimeFigureOut">
               <a:rPr lang="ru-RU" smtClean="0"/>
-              <a:t>02.09.2026</a:t>
+              <a:t>12.09.2026</a:t>
             </a:fld>
             <a:endParaRPr lang="ru-RU"/>
           </a:p>
@@ -2385,7 +2391,7 @@
           <a:p>
             <a:fld id="{93646227-2445-453E-B510-42801F92B7A6}" type="datetimeFigureOut">
               <a:rPr lang="ru-RU" smtClean="0"/>
-              <a:t>02.09.2026</a:t>
+              <a:t>12.09.2026</a:t>
             </a:fld>
             <a:endParaRPr lang="ru-RU"/>
           </a:p>
@@ -2707,7 +2713,7 @@
           <a:p>
             <a:fld id="{93646227-2445-453E-B510-42801F92B7A6}" type="datetimeFigureOut">
               <a:rPr lang="ru-RU" smtClean="0"/>
-              <a:t>02.09.2026</a:t>
+              <a:t>12.09.2026</a:t>
             </a:fld>
             <a:endParaRPr lang="ru-RU"/>
           </a:p>
@@ -2961,7 +2967,7 @@
           <a:p>
             <a:fld id="{93646227-2445-453E-B510-42801F92B7A6}" type="datetimeFigureOut">
               <a:rPr lang="ru-RU" smtClean="0"/>
-              <a:t>02.09.2026</a:t>
+              <a:t>12.09.2026</a:t>
             </a:fld>
             <a:endParaRPr lang="ru-RU"/>
           </a:p>
@@ -3886,6 +3892,61 @@
 </p:sld>
 </file>
 
+<file path=ppt/slides/slide3.xml><?xml version="1.0" encoding="utf-8"?>
+<p:sld xmlns:a="http://schemas.openxmlformats.org/drawingml/2006/main" xmlns:r="http://schemas.openxmlformats.org/officeDocument/2006/relationships" xmlns:p="http://schemas.openxmlformats.org/presentationml/2006/main">
+  <p:cSld>
+    <p:spTree>
+      <p:nvGrpSpPr>
+        <p:cNvPr id="1" name=""/>
+        <p:cNvGrpSpPr/>
+        <p:nvPr/>
+      </p:nvGrpSpPr>
+      <p:grpSpPr>
+        <a:xfrm>
+          <a:off x="0" y="0"/>
+          <a:ext cx="0" cy="0"/>
+          <a:chOff x="0" y="0"/>
+          <a:chExt cx="0" cy="0"/>
+        </a:xfrm>
+      </p:grpSpPr>
+      <p:sp>
+        <p:nvSpPr>
+          <p:cNvPr id="2" name="Заголовок 1">
+            <a:extLst>
+              <a:ext uri="{FF2B5EF4-FFF2-40B4-BE49-F238E27FC236}">
+                <a16:creationId xmlns:a16="http://schemas.microsoft.com/office/drawing/2014/main" id="{A9BB570E-B170-B690-D6C7-70F90ABC4D09}"/>
+              </a:ext>
+            </a:extLst>
+          </p:cNvPr>
+          <p:cNvSpPr>
+            <a:spLocks noGrp="1"/>
+          </p:cNvSpPr>
+          <p:nvPr>
+            <p:ph type="title"/>
+          </p:nvPr>
+        </p:nvSpPr>
+        <p:spPr/>
+        <p:txBody>
+          <a:bodyPr/>
+          <a:lstStyle/>
+          <a:p>
+            <a:endParaRPr lang="ru-RU"/>
+          </a:p>
+        </p:txBody>
+      </p:sp>
+    </p:spTree>
+    <p:extLst>
+      <p:ext uri="{BB962C8B-B14F-4D97-AF65-F5344CB8AC3E}">
+        <p14:creationId xmlns:p14="http://schemas.microsoft.com/office/powerpoint/2010/main" val="3574629071"/>
+      </p:ext>
+    </p:extLst>
+  </p:cSld>
+  <p:clrMapOvr>
+    <a:masterClrMapping/>
+  </p:clrMapOvr>
+</p:sld>
+</file>
+
 <file path=ppt/theme/theme1.xml><?xml version="1.0" encoding="utf-8"?>
 <a:theme xmlns:a="http://schemas.openxmlformats.org/drawingml/2006/main" name="Вид">
   <a:themeElements>

</xml_diff>

<commit_message>
update from app 2026-09-12 09:42:23
</commit_message>
<xml_diff>
--- a/Sergey.pptx
+++ b/Sergey.pptx
@@ -3930,7 +3930,10 @@
           <a:bodyPr/>
           <a:lstStyle/>
           <a:p>
-            <a:endParaRPr lang="ru-RU"/>
+            <a:r>
+              <a:rPr lang="ru-RU"/>
+              <a:t>ПИАЛРВпрлгоап</a:t>
+            </a:r>
           </a:p>
         </p:txBody>
       </p:sp>

</xml_diff>

<commit_message>
update from app 2026-09-12 10:36:09
</commit_message>
<xml_diff>
--- a/Sergey.pptx
+++ b/Sergey.pptx
@@ -3932,8 +3932,9 @@
           <a:p>
             <a:r>
               <a:rPr lang="ru-RU"/>
-              <a:t>ПИАЛРВпрлгоап</a:t>
-            </a:r>
+              <a:t>Привет</a:t>
+            </a:r>
+            <a:endParaRPr lang="ru-RU" dirty="0"/>
           </a:p>
         </p:txBody>
       </p:sp>

</xml_diff>